<commit_message>
Create Client, Master, Service Controllers
</commit_message>
<xml_diff>
--- a/Проект «Маникюрная студия».pptx
+++ b/Проект «Маникюрная студия».pptx
@@ -8,6 +8,8 @@
     <p:sldId id="256" r:id="rId2"/>
     <p:sldId id="257" r:id="rId3"/>
     <p:sldId id="258" r:id="rId4"/>
+    <p:sldId id="259" r:id="rId5"/>
+    <p:sldId id="260" r:id="rId6"/>
   </p:sldIdLst>
   <p:sldSz cx="9144000" cy="6858000" type="screen4x3"/>
   <p:notesSz cx="6858000" cy="9144000"/>
@@ -290,7 +292,8 @@
           <a:p>
             <a:fld id="{6940DC67-C7F6-414D-9708-96C5B560FED9}" type="datetimeFigureOut">
               <a:rPr lang="ru-RU" smtClean="0"/>
-              <a:t>05.06.2026</a:t>
+              <a:pPr/>
+              <a:t>06.06.2026</a:t>
             </a:fld>
             <a:endParaRPr lang="ru-RU"/>
           </a:p>
@@ -332,6 +335,7 @@
           <a:p>
             <a:fld id="{CC37BBF5-46A8-4B2E-946B-D12CFA3CFC41}" type="slidenum">
               <a:rPr lang="ru-RU" smtClean="0"/>
+              <a:pPr/>
               <a:t>‹#›</a:t>
             </a:fld>
             <a:endParaRPr lang="ru-RU"/>
@@ -455,7 +459,8 @@
           <a:p>
             <a:fld id="{6940DC67-C7F6-414D-9708-96C5B560FED9}" type="datetimeFigureOut">
               <a:rPr lang="ru-RU" smtClean="0"/>
-              <a:t>05.06.2026</a:t>
+              <a:pPr/>
+              <a:t>06.06.2026</a:t>
             </a:fld>
             <a:endParaRPr lang="ru-RU"/>
           </a:p>
@@ -497,6 +502,7 @@
           <a:p>
             <a:fld id="{CC37BBF5-46A8-4B2E-946B-D12CFA3CFC41}" type="slidenum">
               <a:rPr lang="ru-RU" smtClean="0"/>
+              <a:pPr/>
               <a:t>‹#›</a:t>
             </a:fld>
             <a:endParaRPr lang="ru-RU"/>
@@ -630,7 +636,8 @@
           <a:p>
             <a:fld id="{6940DC67-C7F6-414D-9708-96C5B560FED9}" type="datetimeFigureOut">
               <a:rPr lang="ru-RU" smtClean="0"/>
-              <a:t>05.06.2026</a:t>
+              <a:pPr/>
+              <a:t>06.06.2026</a:t>
             </a:fld>
             <a:endParaRPr lang="ru-RU"/>
           </a:p>
@@ -672,6 +679,7 @@
           <a:p>
             <a:fld id="{CC37BBF5-46A8-4B2E-946B-D12CFA3CFC41}" type="slidenum">
               <a:rPr lang="ru-RU" smtClean="0"/>
+              <a:pPr/>
               <a:t>‹#›</a:t>
             </a:fld>
             <a:endParaRPr lang="ru-RU"/>
@@ -795,7 +803,8 @@
           <a:p>
             <a:fld id="{6940DC67-C7F6-414D-9708-96C5B560FED9}" type="datetimeFigureOut">
               <a:rPr lang="ru-RU" smtClean="0"/>
-              <a:t>05.06.2026</a:t>
+              <a:pPr/>
+              <a:t>06.06.2026</a:t>
             </a:fld>
             <a:endParaRPr lang="ru-RU"/>
           </a:p>
@@ -837,6 +846,7 @@
           <a:p>
             <a:fld id="{CC37BBF5-46A8-4B2E-946B-D12CFA3CFC41}" type="slidenum">
               <a:rPr lang="ru-RU" smtClean="0"/>
+              <a:pPr/>
               <a:t>‹#›</a:t>
             </a:fld>
             <a:endParaRPr lang="ru-RU"/>
@@ -1036,7 +1046,8 @@
           <a:p>
             <a:fld id="{6940DC67-C7F6-414D-9708-96C5B560FED9}" type="datetimeFigureOut">
               <a:rPr lang="ru-RU" smtClean="0"/>
-              <a:t>05.06.2026</a:t>
+              <a:pPr/>
+              <a:t>06.06.2026</a:t>
             </a:fld>
             <a:endParaRPr lang="ru-RU"/>
           </a:p>
@@ -1078,6 +1089,7 @@
           <a:p>
             <a:fld id="{CC37BBF5-46A8-4B2E-946B-D12CFA3CFC41}" type="slidenum">
               <a:rPr lang="ru-RU" smtClean="0"/>
+              <a:pPr/>
               <a:t>‹#›</a:t>
             </a:fld>
             <a:endParaRPr lang="ru-RU"/>
@@ -1319,7 +1331,8 @@
           <a:p>
             <a:fld id="{6940DC67-C7F6-414D-9708-96C5B560FED9}" type="datetimeFigureOut">
               <a:rPr lang="ru-RU" smtClean="0"/>
-              <a:t>05.06.2026</a:t>
+              <a:pPr/>
+              <a:t>06.06.2026</a:t>
             </a:fld>
             <a:endParaRPr lang="ru-RU"/>
           </a:p>
@@ -1361,6 +1374,7 @@
           <a:p>
             <a:fld id="{CC37BBF5-46A8-4B2E-946B-D12CFA3CFC41}" type="slidenum">
               <a:rPr lang="ru-RU" smtClean="0"/>
+              <a:pPr/>
               <a:t>‹#›</a:t>
             </a:fld>
             <a:endParaRPr lang="ru-RU"/>
@@ -1736,7 +1750,8 @@
           <a:p>
             <a:fld id="{6940DC67-C7F6-414D-9708-96C5B560FED9}" type="datetimeFigureOut">
               <a:rPr lang="ru-RU" smtClean="0"/>
-              <a:t>05.06.2026</a:t>
+              <a:pPr/>
+              <a:t>06.06.2026</a:t>
             </a:fld>
             <a:endParaRPr lang="ru-RU"/>
           </a:p>
@@ -1778,6 +1793,7 @@
           <a:p>
             <a:fld id="{CC37BBF5-46A8-4B2E-946B-D12CFA3CFC41}" type="slidenum">
               <a:rPr lang="ru-RU" smtClean="0"/>
+              <a:pPr/>
               <a:t>‹#›</a:t>
             </a:fld>
             <a:endParaRPr lang="ru-RU"/>
@@ -1849,7 +1865,8 @@
           <a:p>
             <a:fld id="{6940DC67-C7F6-414D-9708-96C5B560FED9}" type="datetimeFigureOut">
               <a:rPr lang="ru-RU" smtClean="0"/>
-              <a:t>05.06.2026</a:t>
+              <a:pPr/>
+              <a:t>06.06.2026</a:t>
             </a:fld>
             <a:endParaRPr lang="ru-RU"/>
           </a:p>
@@ -1891,6 +1908,7 @@
           <a:p>
             <a:fld id="{CC37BBF5-46A8-4B2E-946B-D12CFA3CFC41}" type="slidenum">
               <a:rPr lang="ru-RU" smtClean="0"/>
+              <a:pPr/>
               <a:t>‹#›</a:t>
             </a:fld>
             <a:endParaRPr lang="ru-RU"/>
@@ -1939,7 +1957,8 @@
           <a:p>
             <a:fld id="{6940DC67-C7F6-414D-9708-96C5B560FED9}" type="datetimeFigureOut">
               <a:rPr lang="ru-RU" smtClean="0"/>
-              <a:t>05.06.2026</a:t>
+              <a:pPr/>
+              <a:t>06.06.2026</a:t>
             </a:fld>
             <a:endParaRPr lang="ru-RU"/>
           </a:p>
@@ -1981,6 +2000,7 @@
           <a:p>
             <a:fld id="{CC37BBF5-46A8-4B2E-946B-D12CFA3CFC41}" type="slidenum">
               <a:rPr lang="ru-RU" smtClean="0"/>
+              <a:pPr/>
               <a:t>‹#›</a:t>
             </a:fld>
             <a:endParaRPr lang="ru-RU"/>
@@ -2211,7 +2231,8 @@
           <a:p>
             <a:fld id="{6940DC67-C7F6-414D-9708-96C5B560FED9}" type="datetimeFigureOut">
               <a:rPr lang="ru-RU" smtClean="0"/>
-              <a:t>05.06.2026</a:t>
+              <a:pPr/>
+              <a:t>06.06.2026</a:t>
             </a:fld>
             <a:endParaRPr lang="ru-RU"/>
           </a:p>
@@ -2253,6 +2274,7 @@
           <a:p>
             <a:fld id="{CC37BBF5-46A8-4B2E-946B-D12CFA3CFC41}" type="slidenum">
               <a:rPr lang="ru-RU" smtClean="0"/>
+              <a:pPr/>
               <a:t>‹#›</a:t>
             </a:fld>
             <a:endParaRPr lang="ru-RU"/>
@@ -2459,7 +2481,8 @@
           <a:p>
             <a:fld id="{6940DC67-C7F6-414D-9708-96C5B560FED9}" type="datetimeFigureOut">
               <a:rPr lang="ru-RU" smtClean="0"/>
-              <a:t>05.06.2026</a:t>
+              <a:pPr/>
+              <a:t>06.06.2026</a:t>
             </a:fld>
             <a:endParaRPr lang="ru-RU"/>
           </a:p>
@@ -2501,6 +2524,7 @@
           <a:p>
             <a:fld id="{CC37BBF5-46A8-4B2E-946B-D12CFA3CFC41}" type="slidenum">
               <a:rPr lang="ru-RU" smtClean="0"/>
+              <a:pPr/>
               <a:t>‹#›</a:t>
             </a:fld>
             <a:endParaRPr lang="ru-RU"/>
@@ -2691,7 +2715,8 @@
           <a:p>
             <a:fld id="{6940DC67-C7F6-414D-9708-96C5B560FED9}" type="datetimeFigureOut">
               <a:rPr lang="ru-RU" smtClean="0"/>
-              <a:t>05.06.2026</a:t>
+              <a:pPr/>
+              <a:t>06.06.2026</a:t>
             </a:fld>
             <a:endParaRPr lang="ru-RU"/>
           </a:p>
@@ -2769,6 +2794,7 @@
           <a:p>
             <a:fld id="{CC37BBF5-46A8-4B2E-946B-D12CFA3CFC41}" type="slidenum">
               <a:rPr lang="ru-RU" smtClean="0"/>
+              <a:pPr/>
               <a:t>‹#›</a:t>
             </a:fld>
             <a:endParaRPr lang="ru-RU"/>
@@ -3171,18 +3197,7 @@
                 <a:ea typeface="+mj-ea"/>
                 <a:cs typeface="Times New Roman" pitchFamily="18" charset="0"/>
               </a:rPr>
-              <a:t>. </a:t>
-            </a:r>
-            <a:r>
-              <a:rPr lang="ru-RU" sz="2400" dirty="0">
-                <a:solidFill>
-                  <a:schemeClr val="tx1"/>
-                </a:solidFill>
-                <a:latin typeface="+mj-lt"/>
-                <a:ea typeface="+mj-ea"/>
-                <a:cs typeface="Times New Roman" pitchFamily="18" charset="0"/>
-              </a:rPr>
-              <a:t>Платформа предназначена для учёта клиентов, мастеров, услуг и записей, </a:t>
+              <a:t>. Платформа предназначена для учёта клиентов, мастеров, услуг и записей, </a:t>
             </a:r>
             <a:r>
               <a:rPr lang="ru-RU" sz="2400" dirty="0" smtClean="0">
@@ -3506,14 +3521,7 @@
                 <a:latin typeface="Arial" pitchFamily="34" charset="0"/>
                 <a:cs typeface="Arial" pitchFamily="34" charset="0"/>
               </a:rPr>
-              <a:t>: </a:t>
-            </a:r>
-            <a:r>
-              <a:rPr lang="ru-RU" dirty="0" smtClean="0">
-                <a:latin typeface="Arial" pitchFamily="34" charset="0"/>
-                <a:cs typeface="Arial" pitchFamily="34" charset="0"/>
-              </a:rPr>
-              <a:t>Расписание и клиенты всегда под рукой.</a:t>
+              <a:t>: Расписание и клиенты всегда под рукой.</a:t>
             </a:r>
             <a:endParaRPr lang="en-US" dirty="0" smtClean="0">
               <a:latin typeface="Arial" pitchFamily="34" charset="0"/>
@@ -3526,14 +3534,7 @@
                 <a:latin typeface="Arial" pitchFamily="34" charset="0"/>
                 <a:cs typeface="Arial" pitchFamily="34" charset="0"/>
               </a:rPr>
-              <a:t>Возможность </a:t>
-            </a:r>
-            <a:r>
-              <a:rPr lang="ru-RU" b="1" dirty="0" smtClean="0">
-                <a:latin typeface="Arial" pitchFamily="34" charset="0"/>
-                <a:cs typeface="Arial" pitchFamily="34" charset="0"/>
-              </a:rPr>
-              <a:t>переориентации приложения</a:t>
+              <a:t>Возможность переориентации приложения</a:t>
             </a:r>
             <a:r>
               <a:rPr lang="ru-RU" dirty="0" smtClean="0">
@@ -3771,6 +3772,7 @@
           <a:bodyPr/>
           <a:lstStyle/>
           <a:p>
+            <a:pPr algn="ctr"/>
             <a:r>
               <a:rPr lang="ru-RU" dirty="0" smtClean="0">
                 <a:latin typeface="Arial" pitchFamily="34" charset="0"/>
@@ -3801,12 +3803,31 @@
             <p:ph idx="1"/>
           </p:nvPr>
         </p:nvSpPr>
-        <p:spPr/>
+        <p:spPr>
+          <a:xfrm>
+            <a:off x="3575050" y="836712"/>
+            <a:ext cx="5111750" cy="5289451"/>
+          </a:xfrm>
+        </p:spPr>
         <p:txBody>
           <a:bodyPr/>
           <a:lstStyle/>
           <a:p>
-            <a:endParaRPr lang="ru-RU" dirty="0">
+            <a:r>
+              <a:rPr lang="ru-RU" sz="2000" b="1" dirty="0" smtClean="0">
+                <a:latin typeface="Arial" pitchFamily="34" charset="0"/>
+                <a:cs typeface="Arial" pitchFamily="34" charset="0"/>
+              </a:rPr>
+              <a:t>БАЗА </a:t>
+            </a:r>
+            <a:r>
+              <a:rPr lang="ru-RU" sz="2000" b="1" dirty="0" smtClean="0">
+                <a:latin typeface="Arial" pitchFamily="34" charset="0"/>
+                <a:cs typeface="Arial" pitchFamily="34" charset="0"/>
+              </a:rPr>
+              <a:t>ДАННЫХ</a:t>
+            </a:r>
+            <a:endParaRPr lang="en-US" sz="2000" b="1" dirty="0" smtClean="0">
               <a:latin typeface="Arial" pitchFamily="34" charset="0"/>
               <a:cs typeface="Arial" pitchFamily="34" charset="0"/>
             </a:endParaRPr>
@@ -3835,15 +3856,13 @@
           </a:bodyPr>
           <a:lstStyle/>
           <a:p>
-            <a:pPr marL="342900" indent="-342900">
-              <a:buAutoNum type="arabicParenR"/>
-            </a:pPr>
-            <a:r>
-              <a:rPr lang="ru-RU" sz="1800" b="1" dirty="0" smtClean="0">
-                <a:latin typeface="Arial" pitchFamily="34" charset="0"/>
-                <a:cs typeface="Arial" pitchFamily="34" charset="0"/>
-              </a:rPr>
-              <a:t>БАЗА ДАННЫХ</a:t>
+            <a:pPr marL="342900" indent="-342900" algn="ctr"/>
+            <a:r>
+              <a:rPr lang="ru-RU" sz="2400" b="1" dirty="0" smtClean="0">
+                <a:latin typeface="Arial" pitchFamily="34" charset="0"/>
+                <a:cs typeface="Arial" pitchFamily="34" charset="0"/>
+              </a:rPr>
+              <a:t>Сущности</a:t>
             </a:r>
             <a:endParaRPr lang="en-US" sz="1800" b="1" dirty="0" smtClean="0">
               <a:latin typeface="Arial" pitchFamily="34" charset="0"/>
@@ -3855,13 +3874,1181 @@
               <a:buFont typeface="Arial" pitchFamily="34" charset="0"/>
               <a:buChar char="•"/>
             </a:pPr>
-            <a:endParaRPr lang="ru-RU" sz="1800" b="1" dirty="0" smtClean="0">
+            <a:r>
+              <a:rPr lang="en-US" sz="1800" b="1" dirty="0" err="1" smtClean="0">
+                <a:latin typeface="Arial" pitchFamily="34" charset="0"/>
+                <a:cs typeface="Arial" pitchFamily="34" charset="0"/>
+              </a:rPr>
+              <a:t>BaseEntity</a:t>
+            </a:r>
+            <a:endParaRPr lang="en-US" sz="1800" b="1" dirty="0" smtClean="0">
               <a:latin typeface="Arial" pitchFamily="34" charset="0"/>
               <a:cs typeface="Arial" pitchFamily="34" charset="0"/>
             </a:endParaRPr>
           </a:p>
-        </p:txBody>
-      </p:sp>
+          <a:p>
+            <a:pPr marL="342900" indent="-342900">
+              <a:buFont typeface="Arial" pitchFamily="34" charset="0"/>
+              <a:buChar char="•"/>
+            </a:pPr>
+            <a:endParaRPr lang="en-US" sz="1800" b="1" dirty="0" smtClean="0">
+              <a:latin typeface="Arial" pitchFamily="34" charset="0"/>
+              <a:cs typeface="Arial" pitchFamily="34" charset="0"/>
+            </a:endParaRPr>
+          </a:p>
+          <a:p>
+            <a:pPr marL="342900" indent="-342900">
+              <a:buFont typeface="Arial" pitchFamily="34" charset="0"/>
+              <a:buChar char="•"/>
+            </a:pPr>
+            <a:endParaRPr lang="en-US" sz="1800" b="1" dirty="0" smtClean="0">
+              <a:latin typeface="Arial" pitchFamily="34" charset="0"/>
+              <a:cs typeface="Arial" pitchFamily="34" charset="0"/>
+            </a:endParaRPr>
+          </a:p>
+          <a:p>
+            <a:pPr marL="342900" indent="-342900">
+              <a:buFont typeface="Arial" pitchFamily="34" charset="0"/>
+              <a:buChar char="•"/>
+            </a:pPr>
+            <a:endParaRPr lang="en-US" sz="1800" b="1" dirty="0" smtClean="0">
+              <a:latin typeface="Arial" pitchFamily="34" charset="0"/>
+              <a:cs typeface="Arial" pitchFamily="34" charset="0"/>
+            </a:endParaRPr>
+          </a:p>
+          <a:p>
+            <a:pPr marL="342900" indent="-342900">
+              <a:buFont typeface="Arial" pitchFamily="34" charset="0"/>
+              <a:buChar char="•"/>
+            </a:pPr>
+            <a:r>
+              <a:rPr lang="en-US" sz="1800" b="1" dirty="0" smtClean="0">
+                <a:latin typeface="Arial" pitchFamily="34" charset="0"/>
+                <a:cs typeface="Arial" pitchFamily="34" charset="0"/>
+              </a:rPr>
+              <a:t>Client</a:t>
+            </a:r>
+          </a:p>
+          <a:p>
+            <a:pPr marL="342900" indent="-342900">
+              <a:buFont typeface="Arial" pitchFamily="34" charset="0"/>
+              <a:buChar char="•"/>
+            </a:pPr>
+            <a:endParaRPr lang="en-US" sz="1800" b="1" dirty="0" smtClean="0">
+              <a:latin typeface="Arial" pitchFamily="34" charset="0"/>
+              <a:cs typeface="Arial" pitchFamily="34" charset="0"/>
+            </a:endParaRPr>
+          </a:p>
+          <a:p>
+            <a:pPr marL="342900" indent="-342900">
+              <a:buFont typeface="Arial" pitchFamily="34" charset="0"/>
+              <a:buChar char="•"/>
+            </a:pPr>
+            <a:endParaRPr lang="en-US" sz="1800" b="1" dirty="0" smtClean="0">
+              <a:latin typeface="Arial" pitchFamily="34" charset="0"/>
+              <a:cs typeface="Arial" pitchFamily="34" charset="0"/>
+            </a:endParaRPr>
+          </a:p>
+          <a:p>
+            <a:pPr marL="342900" indent="-342900">
+              <a:buFont typeface="Arial" pitchFamily="34" charset="0"/>
+              <a:buChar char="•"/>
+            </a:pPr>
+            <a:endParaRPr lang="en-US" sz="1800" b="1" dirty="0" smtClean="0">
+              <a:latin typeface="Arial" pitchFamily="34" charset="0"/>
+              <a:cs typeface="Arial" pitchFamily="34" charset="0"/>
+            </a:endParaRPr>
+          </a:p>
+          <a:p>
+            <a:pPr marL="342900" indent="-342900">
+              <a:buFont typeface="Arial" pitchFamily="34" charset="0"/>
+              <a:buChar char="•"/>
+            </a:pPr>
+            <a:endParaRPr lang="en-US" sz="1800" b="1" dirty="0" smtClean="0">
+              <a:latin typeface="Arial" pitchFamily="34" charset="0"/>
+              <a:cs typeface="Arial" pitchFamily="34" charset="0"/>
+            </a:endParaRPr>
+          </a:p>
+          <a:p>
+            <a:pPr marL="342900" indent="-342900">
+              <a:buFont typeface="Arial" pitchFamily="34" charset="0"/>
+              <a:buChar char="•"/>
+            </a:pPr>
+            <a:r>
+              <a:rPr lang="en-US" sz="1800" b="1" dirty="0" smtClean="0">
+                <a:latin typeface="Arial" pitchFamily="34" charset="0"/>
+                <a:cs typeface="Arial" pitchFamily="34" charset="0"/>
+              </a:rPr>
+              <a:t>Master</a:t>
+            </a:r>
+            <a:endParaRPr lang="en-US" sz="1800" b="1" dirty="0" smtClean="0">
+              <a:latin typeface="Arial" pitchFamily="34" charset="0"/>
+              <a:cs typeface="Arial" pitchFamily="34" charset="0"/>
+            </a:endParaRPr>
+          </a:p>
+          <a:p>
+            <a:pPr marL="342900" indent="-342900">
+              <a:buFont typeface="Arial" pitchFamily="34" charset="0"/>
+              <a:buChar char="•"/>
+            </a:pPr>
+            <a:endParaRPr lang="en-US" sz="1800" b="1" dirty="0" smtClean="0">
+              <a:latin typeface="Arial" pitchFamily="34" charset="0"/>
+              <a:cs typeface="Arial" pitchFamily="34" charset="0"/>
+            </a:endParaRPr>
+          </a:p>
+          <a:p>
+            <a:pPr marL="342900" indent="-342900">
+              <a:buFont typeface="Arial" pitchFamily="34" charset="0"/>
+              <a:buChar char="•"/>
+            </a:pPr>
+            <a:endParaRPr lang="en-US" sz="1800" b="1" dirty="0" smtClean="0">
+              <a:latin typeface="Arial" pitchFamily="34" charset="0"/>
+              <a:cs typeface="Arial" pitchFamily="34" charset="0"/>
+            </a:endParaRPr>
+          </a:p>
+        </p:txBody>
+      </p:sp>
+      <p:pic>
+        <p:nvPicPr>
+          <p:cNvPr id="1026" name="Picture 2"/>
+          <p:cNvPicPr>
+            <a:picLocks noChangeAspect="1" noChangeArrowheads="1"/>
+          </p:cNvPicPr>
+          <p:nvPr/>
+        </p:nvPicPr>
+        <p:blipFill>
+          <a:blip r:embed="rId2" cstate="print"/>
+          <a:srcRect/>
+          <a:stretch>
+            <a:fillRect/>
+          </a:stretch>
+        </p:blipFill>
+        <p:spPr bwMode="auto">
+          <a:xfrm>
+            <a:off x="3779912" y="2636912"/>
+            <a:ext cx="4889831" cy="1538708"/>
+          </a:xfrm>
+          <a:prstGeom prst="rect">
+            <a:avLst/>
+          </a:prstGeom>
+          <a:noFill/>
+          <a:ln w="9525">
+            <a:noFill/>
+            <a:miter lim="800000"/>
+            <a:headEnd/>
+            <a:tailEnd/>
+          </a:ln>
+          <a:effectLst/>
+        </p:spPr>
+      </p:pic>
+      <p:pic>
+        <p:nvPicPr>
+          <p:cNvPr id="1027" name="Picture 3"/>
+          <p:cNvPicPr>
+            <a:picLocks noChangeAspect="1" noChangeArrowheads="1"/>
+          </p:cNvPicPr>
+          <p:nvPr/>
+        </p:nvPicPr>
+        <p:blipFill>
+          <a:blip r:embed="rId3" cstate="print"/>
+          <a:srcRect/>
+          <a:stretch>
+            <a:fillRect/>
+          </a:stretch>
+        </p:blipFill>
+        <p:spPr bwMode="auto">
+          <a:xfrm>
+            <a:off x="3131840" y="4293096"/>
+            <a:ext cx="5873652" cy="2154573"/>
+          </a:xfrm>
+          <a:prstGeom prst="rect">
+            <a:avLst/>
+          </a:prstGeom>
+          <a:noFill/>
+          <a:ln w="9525">
+            <a:noFill/>
+            <a:miter lim="800000"/>
+            <a:headEnd/>
+            <a:tailEnd/>
+          </a:ln>
+          <a:effectLst/>
+        </p:spPr>
+      </p:pic>
+      <p:pic>
+        <p:nvPicPr>
+          <p:cNvPr id="1028" name="Picture 4"/>
+          <p:cNvPicPr>
+            <a:picLocks noChangeAspect="1" noChangeArrowheads="1"/>
+          </p:cNvPicPr>
+          <p:nvPr/>
+        </p:nvPicPr>
+        <p:blipFill>
+          <a:blip r:embed="rId4" cstate="print"/>
+          <a:srcRect/>
+          <a:stretch>
+            <a:fillRect/>
+          </a:stretch>
+        </p:blipFill>
+        <p:spPr bwMode="auto">
+          <a:xfrm>
+            <a:off x="3779912" y="1268760"/>
+            <a:ext cx="4645249" cy="1090158"/>
+          </a:xfrm>
+          <a:prstGeom prst="rect">
+            <a:avLst/>
+          </a:prstGeom>
+          <a:noFill/>
+          <a:ln w="9525">
+            <a:noFill/>
+            <a:miter lim="800000"/>
+            <a:headEnd/>
+            <a:tailEnd/>
+          </a:ln>
+          <a:effectLst/>
+        </p:spPr>
+      </p:pic>
+    </p:spTree>
+  </p:cSld>
+  <p:clrMapOvr>
+    <a:masterClrMapping/>
+  </p:clrMapOvr>
+</p:sld>
+</file>
+
+<file path=ppt/slides/slide4.xml><?xml version="1.0" encoding="utf-8"?>
+<p:sld xmlns:a="http://schemas.openxmlformats.org/drawingml/2006/main" xmlns:r="http://schemas.openxmlformats.org/officeDocument/2006/relationships" xmlns:p="http://schemas.openxmlformats.org/presentationml/2006/main">
+  <p:cSld>
+    <p:spTree>
+      <p:nvGrpSpPr>
+        <p:cNvPr id="1" name=""/>
+        <p:cNvGrpSpPr/>
+        <p:nvPr/>
+      </p:nvGrpSpPr>
+      <p:grpSpPr>
+        <a:xfrm>
+          <a:off x="0" y="0"/>
+          <a:ext cx="0" cy="0"/>
+          <a:chOff x="0" y="0"/>
+          <a:chExt cx="0" cy="0"/>
+        </a:xfrm>
+      </p:grpSpPr>
+      <p:sp>
+        <p:nvSpPr>
+          <p:cNvPr id="4" name="Текст 3"/>
+          <p:cNvSpPr>
+            <a:spLocks noGrp="1"/>
+          </p:cNvSpPr>
+          <p:nvPr>
+            <p:ph type="body" sz="half" idx="2"/>
+          </p:nvPr>
+        </p:nvSpPr>
+        <p:spPr>
+          <a:xfrm>
+            <a:off x="457201" y="332656"/>
+            <a:ext cx="2962672" cy="6336704"/>
+          </a:xfrm>
+        </p:spPr>
+        <p:txBody>
+          <a:bodyPr>
+            <a:noAutofit/>
+          </a:bodyPr>
+          <a:lstStyle/>
+          <a:p>
+            <a:pPr marL="342900" indent="-342900">
+              <a:buFont typeface="Arial" pitchFamily="34" charset="0"/>
+              <a:buChar char="•"/>
+            </a:pPr>
+            <a:r>
+              <a:rPr lang="en-US" sz="1800" b="1" dirty="0" smtClean="0">
+                <a:latin typeface="Arial" pitchFamily="34" charset="0"/>
+                <a:cs typeface="Arial" pitchFamily="34" charset="0"/>
+              </a:rPr>
+              <a:t>Service</a:t>
+            </a:r>
+          </a:p>
+          <a:p>
+            <a:pPr marL="342900" indent="-342900">
+              <a:buFont typeface="Arial" pitchFamily="34" charset="0"/>
+              <a:buChar char="•"/>
+            </a:pPr>
+            <a:endParaRPr lang="en-US" sz="1800" b="1" dirty="0" smtClean="0">
+              <a:latin typeface="Arial" pitchFamily="34" charset="0"/>
+              <a:cs typeface="Arial" pitchFamily="34" charset="0"/>
+            </a:endParaRPr>
+          </a:p>
+          <a:p>
+            <a:pPr marL="342900" indent="-342900">
+              <a:buFont typeface="Arial" pitchFamily="34" charset="0"/>
+              <a:buChar char="•"/>
+            </a:pPr>
+            <a:endParaRPr lang="en-US" sz="1800" b="1" dirty="0" smtClean="0">
+              <a:latin typeface="Arial" pitchFamily="34" charset="0"/>
+              <a:cs typeface="Arial" pitchFamily="34" charset="0"/>
+            </a:endParaRPr>
+          </a:p>
+          <a:p>
+            <a:pPr marL="342900" indent="-342900">
+              <a:buFont typeface="Arial" pitchFamily="34" charset="0"/>
+              <a:buChar char="•"/>
+            </a:pPr>
+            <a:endParaRPr lang="en-US" sz="1800" b="1" dirty="0" smtClean="0">
+              <a:latin typeface="Arial" pitchFamily="34" charset="0"/>
+              <a:cs typeface="Arial" pitchFamily="34" charset="0"/>
+            </a:endParaRPr>
+          </a:p>
+          <a:p>
+            <a:pPr marL="342900" indent="-342900">
+              <a:buFont typeface="Arial" pitchFamily="34" charset="0"/>
+              <a:buChar char="•"/>
+            </a:pPr>
+            <a:endParaRPr lang="en-US" sz="1800" b="1" dirty="0" smtClean="0">
+              <a:latin typeface="Arial" pitchFamily="34" charset="0"/>
+              <a:cs typeface="Arial" pitchFamily="34" charset="0"/>
+            </a:endParaRPr>
+          </a:p>
+          <a:p>
+            <a:pPr marL="342900" indent="-342900">
+              <a:buFont typeface="Arial" pitchFamily="34" charset="0"/>
+              <a:buChar char="•"/>
+            </a:pPr>
+            <a:r>
+              <a:rPr lang="en-US" sz="1800" b="1" dirty="0" smtClean="0">
+                <a:latin typeface="Arial" pitchFamily="34" charset="0"/>
+                <a:cs typeface="Arial" pitchFamily="34" charset="0"/>
+              </a:rPr>
+              <a:t>Appointment</a:t>
+            </a:r>
+          </a:p>
+          <a:p>
+            <a:pPr marL="342900" indent="-342900">
+              <a:buFont typeface="Arial" pitchFamily="34" charset="0"/>
+              <a:buChar char="•"/>
+            </a:pPr>
+            <a:endParaRPr lang="en-US" sz="1800" b="1" dirty="0" smtClean="0">
+              <a:latin typeface="Arial" pitchFamily="34" charset="0"/>
+              <a:cs typeface="Arial" pitchFamily="34" charset="0"/>
+            </a:endParaRPr>
+          </a:p>
+          <a:p>
+            <a:pPr marL="342900" indent="-342900">
+              <a:buFont typeface="Arial" pitchFamily="34" charset="0"/>
+              <a:buChar char="•"/>
+            </a:pPr>
+            <a:endParaRPr lang="en-US" sz="1800" b="1" dirty="0" smtClean="0">
+              <a:latin typeface="Arial" pitchFamily="34" charset="0"/>
+              <a:cs typeface="Arial" pitchFamily="34" charset="0"/>
+            </a:endParaRPr>
+          </a:p>
+          <a:p>
+            <a:pPr marL="342900" indent="-342900">
+              <a:buFont typeface="Arial" pitchFamily="34" charset="0"/>
+              <a:buChar char="•"/>
+            </a:pPr>
+            <a:endParaRPr lang="en-US" sz="1800" b="1" dirty="0" smtClean="0">
+              <a:latin typeface="Arial" pitchFamily="34" charset="0"/>
+              <a:cs typeface="Arial" pitchFamily="34" charset="0"/>
+            </a:endParaRPr>
+          </a:p>
+          <a:p>
+            <a:pPr marL="342900" indent="-342900">
+              <a:buFont typeface="Arial" pitchFamily="34" charset="0"/>
+              <a:buChar char="•"/>
+            </a:pPr>
+            <a:endParaRPr lang="en-US" sz="1800" b="1" dirty="0" smtClean="0">
+              <a:latin typeface="Arial" pitchFamily="34" charset="0"/>
+              <a:cs typeface="Arial" pitchFamily="34" charset="0"/>
+            </a:endParaRPr>
+          </a:p>
+          <a:p>
+            <a:pPr marL="342900" indent="-342900">
+              <a:buFont typeface="Arial" pitchFamily="34" charset="0"/>
+              <a:buChar char="•"/>
+            </a:pPr>
+            <a:r>
+              <a:rPr lang="en-US" sz="1800" b="1" dirty="0" smtClean="0">
+                <a:latin typeface="Arial" pitchFamily="34" charset="0"/>
+                <a:cs typeface="Arial" pitchFamily="34" charset="0"/>
+              </a:rPr>
+              <a:t>Appointment</a:t>
+            </a:r>
+          </a:p>
+          <a:p>
+            <a:pPr marL="342900" indent="-342900"/>
+            <a:r>
+              <a:rPr lang="en-US" sz="1800" b="1" dirty="0" smtClean="0">
+                <a:latin typeface="Arial" pitchFamily="34" charset="0"/>
+                <a:cs typeface="Arial" pitchFamily="34" charset="0"/>
+              </a:rPr>
+              <a:t>Service</a:t>
+            </a:r>
+          </a:p>
+          <a:p>
+            <a:pPr marL="342900" indent="-342900"/>
+            <a:endParaRPr lang="en-US" sz="1800" b="1" dirty="0" smtClean="0">
+              <a:latin typeface="Arial" pitchFamily="34" charset="0"/>
+              <a:cs typeface="Arial" pitchFamily="34" charset="0"/>
+            </a:endParaRPr>
+          </a:p>
+          <a:p>
+            <a:pPr marL="342900" indent="-342900"/>
+            <a:endParaRPr lang="en-US" sz="1800" b="1" dirty="0" smtClean="0">
+              <a:latin typeface="Arial" pitchFamily="34" charset="0"/>
+              <a:cs typeface="Arial" pitchFamily="34" charset="0"/>
+            </a:endParaRPr>
+          </a:p>
+          <a:p>
+            <a:pPr marL="342900" indent="-342900">
+              <a:buFont typeface="Arial" pitchFamily="34" charset="0"/>
+              <a:buChar char="•"/>
+            </a:pPr>
+            <a:r>
+              <a:rPr lang="en-US" sz="1800" b="1" dirty="0" smtClean="0">
+                <a:latin typeface="Arial" pitchFamily="34" charset="0"/>
+                <a:cs typeface="Arial" pitchFamily="34" charset="0"/>
+              </a:rPr>
+              <a:t>Master</a:t>
+            </a:r>
+          </a:p>
+          <a:p>
+            <a:pPr marL="342900" indent="-342900"/>
+            <a:r>
+              <a:rPr lang="en-US" sz="1800" b="1" dirty="0" smtClean="0">
+                <a:latin typeface="Arial" pitchFamily="34" charset="0"/>
+                <a:cs typeface="Arial" pitchFamily="34" charset="0"/>
+              </a:rPr>
+              <a:t>Service</a:t>
+            </a:r>
+          </a:p>
+          <a:p>
+            <a:pPr marL="342900" indent="-342900"/>
+            <a:endParaRPr lang="en-US" sz="1800" b="1" dirty="0" smtClean="0">
+              <a:latin typeface="Arial" pitchFamily="34" charset="0"/>
+              <a:cs typeface="Arial" pitchFamily="34" charset="0"/>
+            </a:endParaRPr>
+          </a:p>
+          <a:p>
+            <a:pPr marL="342900" indent="-342900">
+              <a:buFont typeface="Arial" pitchFamily="34" charset="0"/>
+              <a:buChar char="•"/>
+            </a:pPr>
+            <a:r>
+              <a:rPr lang="en-US" sz="1800" b="1" dirty="0" smtClean="0">
+                <a:latin typeface="Arial" pitchFamily="34" charset="0"/>
+                <a:cs typeface="Arial" pitchFamily="34" charset="0"/>
+              </a:rPr>
+              <a:t>Service Category</a:t>
+            </a:r>
+          </a:p>
+        </p:txBody>
+      </p:sp>
+      <p:pic>
+        <p:nvPicPr>
+          <p:cNvPr id="2051" name="Picture 3"/>
+          <p:cNvPicPr>
+            <a:picLocks noChangeAspect="1" noChangeArrowheads="1"/>
+          </p:cNvPicPr>
+          <p:nvPr/>
+        </p:nvPicPr>
+        <p:blipFill>
+          <a:blip r:embed="rId2" cstate="print"/>
+          <a:srcRect/>
+          <a:stretch>
+            <a:fillRect/>
+          </a:stretch>
+        </p:blipFill>
+        <p:spPr bwMode="auto">
+          <a:xfrm>
+            <a:off x="2915816" y="188640"/>
+            <a:ext cx="5273429" cy="1390387"/>
+          </a:xfrm>
+          <a:prstGeom prst="rect">
+            <a:avLst/>
+          </a:prstGeom>
+          <a:noFill/>
+          <a:ln w="9525">
+            <a:noFill/>
+            <a:miter lim="800000"/>
+            <a:headEnd/>
+            <a:tailEnd/>
+          </a:ln>
+          <a:effectLst/>
+        </p:spPr>
+      </p:pic>
+      <p:pic>
+        <p:nvPicPr>
+          <p:cNvPr id="2052" name="Picture 4"/>
+          <p:cNvPicPr>
+            <a:picLocks noGrp="1" noChangeAspect="1" noChangeArrowheads="1"/>
+          </p:cNvPicPr>
+          <p:nvPr>
+            <p:ph idx="1"/>
+          </p:nvPr>
+        </p:nvPicPr>
+        <p:blipFill>
+          <a:blip r:embed="rId3" cstate="print"/>
+          <a:srcRect/>
+          <a:stretch>
+            <a:fillRect/>
+          </a:stretch>
+        </p:blipFill>
+        <p:spPr bwMode="auto">
+          <a:xfrm>
+            <a:off x="2915816" y="1628800"/>
+            <a:ext cx="5328592" cy="1611940"/>
+          </a:xfrm>
+          <a:prstGeom prst="rect">
+            <a:avLst/>
+          </a:prstGeom>
+          <a:noFill/>
+          <a:ln w="9525">
+            <a:noFill/>
+            <a:miter lim="800000"/>
+            <a:headEnd/>
+            <a:tailEnd/>
+          </a:ln>
+          <a:effectLst/>
+        </p:spPr>
+      </p:pic>
+      <p:pic>
+        <p:nvPicPr>
+          <p:cNvPr id="2053" name="Picture 5"/>
+          <p:cNvPicPr>
+            <a:picLocks noChangeAspect="1" noChangeArrowheads="1"/>
+          </p:cNvPicPr>
+          <p:nvPr/>
+        </p:nvPicPr>
+        <p:blipFill>
+          <a:blip r:embed="rId4" cstate="print"/>
+          <a:srcRect/>
+          <a:stretch>
+            <a:fillRect/>
+          </a:stretch>
+        </p:blipFill>
+        <p:spPr bwMode="auto">
+          <a:xfrm>
+            <a:off x="2915816" y="3284984"/>
+            <a:ext cx="4941153" cy="1220789"/>
+          </a:xfrm>
+          <a:prstGeom prst="rect">
+            <a:avLst/>
+          </a:prstGeom>
+          <a:noFill/>
+          <a:ln w="9525">
+            <a:noFill/>
+            <a:miter lim="800000"/>
+            <a:headEnd/>
+            <a:tailEnd/>
+          </a:ln>
+          <a:effectLst/>
+        </p:spPr>
+      </p:pic>
+      <p:pic>
+        <p:nvPicPr>
+          <p:cNvPr id="2054" name="Picture 6"/>
+          <p:cNvPicPr>
+            <a:picLocks noChangeAspect="1" noChangeArrowheads="1"/>
+          </p:cNvPicPr>
+          <p:nvPr/>
+        </p:nvPicPr>
+        <p:blipFill>
+          <a:blip r:embed="rId5" cstate="print"/>
+          <a:srcRect/>
+          <a:stretch>
+            <a:fillRect/>
+          </a:stretch>
+        </p:blipFill>
+        <p:spPr bwMode="auto">
+          <a:xfrm>
+            <a:off x="2915816" y="4581128"/>
+            <a:ext cx="2546797" cy="1059287"/>
+          </a:xfrm>
+          <a:prstGeom prst="rect">
+            <a:avLst/>
+          </a:prstGeom>
+          <a:noFill/>
+          <a:ln w="9525">
+            <a:noFill/>
+            <a:miter lim="800000"/>
+            <a:headEnd/>
+            <a:tailEnd/>
+          </a:ln>
+          <a:effectLst/>
+        </p:spPr>
+      </p:pic>
+      <p:pic>
+        <p:nvPicPr>
+          <p:cNvPr id="2055" name="Picture 7"/>
+          <p:cNvPicPr>
+            <a:picLocks noChangeAspect="1" noChangeArrowheads="1"/>
+          </p:cNvPicPr>
+          <p:nvPr/>
+        </p:nvPicPr>
+        <p:blipFill>
+          <a:blip r:embed="rId6" cstate="print"/>
+          <a:srcRect/>
+          <a:stretch>
+            <a:fillRect/>
+          </a:stretch>
+        </p:blipFill>
+        <p:spPr bwMode="auto">
+          <a:xfrm>
+            <a:off x="2915816" y="5805264"/>
+            <a:ext cx="3460254" cy="792512"/>
+          </a:xfrm>
+          <a:prstGeom prst="rect">
+            <a:avLst/>
+          </a:prstGeom>
+          <a:noFill/>
+          <a:ln w="9525">
+            <a:noFill/>
+            <a:miter lim="800000"/>
+            <a:headEnd/>
+            <a:tailEnd/>
+          </a:ln>
+          <a:effectLst/>
+        </p:spPr>
+      </p:pic>
+    </p:spTree>
+  </p:cSld>
+  <p:clrMapOvr>
+    <a:masterClrMapping/>
+  </p:clrMapOvr>
+</p:sld>
+</file>
+
+<file path=ppt/slides/slide5.xml><?xml version="1.0" encoding="utf-8"?>
+<p:sld xmlns:a="http://schemas.openxmlformats.org/drawingml/2006/main" xmlns:r="http://schemas.openxmlformats.org/officeDocument/2006/relationships" xmlns:p="http://schemas.openxmlformats.org/presentationml/2006/main">
+  <p:cSld>
+    <p:spTree>
+      <p:nvGrpSpPr>
+        <p:cNvPr id="1" name=""/>
+        <p:cNvGrpSpPr/>
+        <p:nvPr/>
+      </p:nvGrpSpPr>
+      <p:grpSpPr>
+        <a:xfrm>
+          <a:off x="0" y="0"/>
+          <a:ext cx="0" cy="0"/>
+          <a:chOff x="0" y="0"/>
+          <a:chExt cx="0" cy="0"/>
+        </a:xfrm>
+      </p:grpSpPr>
+      <p:sp>
+        <p:nvSpPr>
+          <p:cNvPr id="2" name="Заголовок 1"/>
+          <p:cNvSpPr>
+            <a:spLocks noGrp="1"/>
+          </p:cNvSpPr>
+          <p:nvPr>
+            <p:ph type="title"/>
+          </p:nvPr>
+        </p:nvSpPr>
+        <p:spPr>
+          <a:xfrm>
+            <a:off x="457200" y="273050"/>
+            <a:ext cx="4402832" cy="779686"/>
+          </a:xfrm>
+        </p:spPr>
+        <p:txBody>
+          <a:bodyPr>
+            <a:noAutofit/>
+          </a:bodyPr>
+          <a:lstStyle/>
+          <a:p>
+            <a:pPr algn="ctr"/>
+            <a:r>
+              <a:rPr lang="ru-RU" sz="2800" dirty="0" smtClean="0">
+                <a:latin typeface="Arial" pitchFamily="34" charset="0"/>
+                <a:cs typeface="Arial" pitchFamily="34" charset="0"/>
+              </a:rPr>
+              <a:t>Схема базы данных</a:t>
+            </a:r>
+            <a:r>
+              <a:rPr lang="ru-RU" sz="2800" dirty="0" smtClean="0">
+                <a:latin typeface="Arial" pitchFamily="34" charset="0"/>
+                <a:cs typeface="Arial" pitchFamily="34" charset="0"/>
+              </a:rPr>
+              <a:t/>
+            </a:r>
+            <a:br>
+              <a:rPr lang="ru-RU" sz="2800" dirty="0" smtClean="0">
+                <a:latin typeface="Arial" pitchFamily="34" charset="0"/>
+                <a:cs typeface="Arial" pitchFamily="34" charset="0"/>
+              </a:rPr>
+            </a:br>
+            <a:endParaRPr lang="ru-RU" sz="2800" dirty="0"/>
+          </a:p>
+        </p:txBody>
+      </p:sp>
+      <p:sp>
+        <p:nvSpPr>
+          <p:cNvPr id="3" name="Содержимое 2"/>
+          <p:cNvSpPr>
+            <a:spLocks noGrp="1"/>
+          </p:cNvSpPr>
+          <p:nvPr>
+            <p:ph idx="1"/>
+          </p:nvPr>
+        </p:nvSpPr>
+        <p:spPr/>
+        <p:txBody>
+          <a:bodyPr/>
+          <a:lstStyle/>
+          <a:p>
+            <a:endParaRPr lang="ru-RU" sz="2400" dirty="0" smtClean="0"/>
+          </a:p>
+          <a:p>
+            <a:pPr algn="ctr"/>
+            <a:r>
+              <a:rPr lang="ru-RU" sz="2400" dirty="0" smtClean="0"/>
+              <a:t>Диаграмма БД</a:t>
+            </a:r>
+            <a:endParaRPr lang="ru-RU" dirty="0"/>
+          </a:p>
+        </p:txBody>
+      </p:sp>
+      <p:sp>
+        <p:nvSpPr>
+          <p:cNvPr id="4" name="Текст 3"/>
+          <p:cNvSpPr>
+            <a:spLocks noGrp="1"/>
+          </p:cNvSpPr>
+          <p:nvPr>
+            <p:ph type="body" sz="half" idx="2"/>
+          </p:nvPr>
+        </p:nvSpPr>
+        <p:spPr>
+          <a:xfrm>
+            <a:off x="179512" y="1124744"/>
+            <a:ext cx="4464496" cy="5051103"/>
+          </a:xfrm>
+        </p:spPr>
+        <p:txBody>
+          <a:bodyPr>
+            <a:normAutofit/>
+          </a:bodyPr>
+          <a:lstStyle/>
+          <a:p>
+            <a:r>
+              <a:rPr lang="ru-RU" dirty="0" smtClean="0">
+                <a:latin typeface="Arial" pitchFamily="34" charset="0"/>
+                <a:cs typeface="Arial" pitchFamily="34" charset="0"/>
+              </a:rPr>
+              <a:t>Таблица </a:t>
+            </a:r>
+            <a:r>
+              <a:rPr lang="en-US" dirty="0" smtClean="0">
+                <a:latin typeface="Arial" pitchFamily="34" charset="0"/>
+                <a:cs typeface="Arial" pitchFamily="34" charset="0"/>
+              </a:rPr>
+              <a:t>Clients</a:t>
+            </a:r>
+          </a:p>
+          <a:p>
+            <a:r>
+              <a:rPr lang="ru-RU" dirty="0" smtClean="0">
+                <a:latin typeface="Arial" pitchFamily="34" charset="0"/>
+                <a:cs typeface="Arial" pitchFamily="34" charset="0"/>
+              </a:rPr>
+              <a:t> (Клиенты)</a:t>
+            </a:r>
+          </a:p>
+          <a:p>
+            <a:r>
+              <a:rPr lang="ru-RU" dirty="0" smtClean="0">
+                <a:latin typeface="Arial" pitchFamily="34" charset="0"/>
+                <a:cs typeface="Arial" pitchFamily="34" charset="0"/>
+              </a:rPr>
+              <a:t>Таблица </a:t>
+            </a:r>
+            <a:r>
+              <a:rPr lang="en-US" dirty="0" smtClean="0">
+                <a:latin typeface="Arial" pitchFamily="34" charset="0"/>
+                <a:cs typeface="Arial" pitchFamily="34" charset="0"/>
+              </a:rPr>
+              <a:t>Masters</a:t>
+            </a:r>
+            <a:r>
+              <a:rPr lang="ru-RU" dirty="0" smtClean="0">
+                <a:latin typeface="Arial" pitchFamily="34" charset="0"/>
+                <a:cs typeface="Arial" pitchFamily="34" charset="0"/>
+              </a:rPr>
+              <a:t> </a:t>
+            </a:r>
+            <a:endParaRPr lang="en-US" dirty="0" smtClean="0">
+              <a:latin typeface="Arial" pitchFamily="34" charset="0"/>
+              <a:cs typeface="Arial" pitchFamily="34" charset="0"/>
+            </a:endParaRPr>
+          </a:p>
+          <a:p>
+            <a:r>
+              <a:rPr lang="ru-RU" dirty="0" smtClean="0">
+                <a:latin typeface="Arial" pitchFamily="34" charset="0"/>
+                <a:cs typeface="Arial" pitchFamily="34" charset="0"/>
+              </a:rPr>
+              <a:t>(Мастера)</a:t>
+            </a:r>
+          </a:p>
+          <a:p>
+            <a:r>
+              <a:rPr lang="ru-RU" dirty="0" smtClean="0">
+                <a:latin typeface="Arial" pitchFamily="34" charset="0"/>
+                <a:cs typeface="Arial" pitchFamily="34" charset="0"/>
+              </a:rPr>
+              <a:t>Таблица </a:t>
+            </a:r>
+            <a:r>
+              <a:rPr lang="en-US" dirty="0" smtClean="0">
+                <a:latin typeface="Arial" pitchFamily="34" charset="0"/>
+                <a:cs typeface="Arial" pitchFamily="34" charset="0"/>
+              </a:rPr>
+              <a:t>Services</a:t>
+            </a:r>
+          </a:p>
+          <a:p>
+            <a:r>
+              <a:rPr lang="ru-RU" dirty="0" smtClean="0">
+                <a:latin typeface="Arial" pitchFamily="34" charset="0"/>
+                <a:cs typeface="Arial" pitchFamily="34" charset="0"/>
+              </a:rPr>
+              <a:t> (Услуги)</a:t>
+            </a:r>
+          </a:p>
+          <a:p>
+            <a:r>
+              <a:rPr lang="ru-RU" dirty="0" smtClean="0">
+                <a:latin typeface="Arial" pitchFamily="34" charset="0"/>
+                <a:cs typeface="Arial" pitchFamily="34" charset="0"/>
+              </a:rPr>
+              <a:t>Таблица </a:t>
+            </a:r>
+            <a:r>
+              <a:rPr lang="en-US" dirty="0" smtClean="0">
+                <a:latin typeface="Arial" pitchFamily="34" charset="0"/>
+                <a:cs typeface="Arial" pitchFamily="34" charset="0"/>
+              </a:rPr>
+              <a:t>Appointments</a:t>
+            </a:r>
+            <a:r>
+              <a:rPr lang="ru-RU" dirty="0" smtClean="0">
+                <a:latin typeface="Arial" pitchFamily="34" charset="0"/>
+                <a:cs typeface="Arial" pitchFamily="34" charset="0"/>
+              </a:rPr>
+              <a:t> </a:t>
+            </a:r>
+            <a:endParaRPr lang="en-US" dirty="0" smtClean="0">
+              <a:latin typeface="Arial" pitchFamily="34" charset="0"/>
+              <a:cs typeface="Arial" pitchFamily="34" charset="0"/>
+            </a:endParaRPr>
+          </a:p>
+          <a:p>
+            <a:r>
+              <a:rPr lang="ru-RU" dirty="0" smtClean="0">
+                <a:latin typeface="Arial" pitchFamily="34" charset="0"/>
+                <a:cs typeface="Arial" pitchFamily="34" charset="0"/>
+              </a:rPr>
+              <a:t>(Записи </a:t>
+            </a:r>
+            <a:r>
+              <a:rPr lang="ru-RU" dirty="0" smtClean="0">
+                <a:latin typeface="Arial" pitchFamily="34" charset="0"/>
+                <a:cs typeface="Arial" pitchFamily="34" charset="0"/>
+              </a:rPr>
+              <a:t>на приём</a:t>
+            </a:r>
+            <a:r>
+              <a:rPr lang="ru-RU" dirty="0" smtClean="0">
+                <a:latin typeface="Arial" pitchFamily="34" charset="0"/>
+                <a:cs typeface="Arial" pitchFamily="34" charset="0"/>
+              </a:rPr>
+              <a:t>)</a:t>
+            </a:r>
+          </a:p>
+          <a:p>
+            <a:r>
+              <a:rPr lang="ru-RU" dirty="0" smtClean="0">
+                <a:latin typeface="Arial" pitchFamily="34" charset="0"/>
+                <a:cs typeface="Arial" pitchFamily="34" charset="0"/>
+              </a:rPr>
+              <a:t>Таблица </a:t>
+            </a:r>
+            <a:r>
+              <a:rPr lang="ru-RU" dirty="0" err="1" smtClean="0">
+                <a:latin typeface="Arial" pitchFamily="34" charset="0"/>
+                <a:cs typeface="Arial" pitchFamily="34" charset="0"/>
+              </a:rPr>
+              <a:t>AppointmentServices</a:t>
+            </a:r>
+            <a:r>
+              <a:rPr lang="ru-RU" dirty="0" smtClean="0">
+                <a:latin typeface="Arial" pitchFamily="34" charset="0"/>
+                <a:cs typeface="Arial" pitchFamily="34" charset="0"/>
+              </a:rPr>
+              <a:t> </a:t>
+            </a:r>
+            <a:endParaRPr lang="en-US" dirty="0" smtClean="0">
+              <a:latin typeface="Arial" pitchFamily="34" charset="0"/>
+              <a:cs typeface="Arial" pitchFamily="34" charset="0"/>
+            </a:endParaRPr>
+          </a:p>
+          <a:p>
+            <a:r>
+              <a:rPr lang="ru-RU" dirty="0" smtClean="0">
+                <a:latin typeface="Arial" pitchFamily="34" charset="0"/>
+                <a:cs typeface="Arial" pitchFamily="34" charset="0"/>
+              </a:rPr>
+              <a:t>(</a:t>
+            </a:r>
+            <a:r>
+              <a:rPr lang="ru-RU" dirty="0" smtClean="0">
+                <a:latin typeface="Arial" pitchFamily="34" charset="0"/>
+                <a:cs typeface="Arial" pitchFamily="34" charset="0"/>
+              </a:rPr>
+              <a:t>Услуги в </a:t>
+            </a:r>
+            <a:r>
+              <a:rPr lang="ru-RU" dirty="0" smtClean="0">
+                <a:latin typeface="Arial" pitchFamily="34" charset="0"/>
+                <a:cs typeface="Arial" pitchFamily="34" charset="0"/>
+              </a:rPr>
+              <a:t>записи)</a:t>
+            </a:r>
+          </a:p>
+          <a:p>
+            <a:r>
+              <a:rPr lang="ru-RU" dirty="0" smtClean="0">
+                <a:latin typeface="Arial" pitchFamily="34" charset="0"/>
+                <a:cs typeface="Arial" pitchFamily="34" charset="0"/>
+              </a:rPr>
+              <a:t>Таблица </a:t>
+            </a:r>
+            <a:r>
+              <a:rPr lang="ru-RU" dirty="0" err="1" smtClean="0">
+                <a:latin typeface="Arial" pitchFamily="34" charset="0"/>
+                <a:cs typeface="Arial" pitchFamily="34" charset="0"/>
+              </a:rPr>
+              <a:t>MasterServices</a:t>
+            </a:r>
+            <a:endParaRPr lang="en-US" dirty="0" smtClean="0">
+              <a:latin typeface="Arial" pitchFamily="34" charset="0"/>
+              <a:cs typeface="Arial" pitchFamily="34" charset="0"/>
+            </a:endParaRPr>
+          </a:p>
+          <a:p>
+            <a:r>
+              <a:rPr lang="ru-RU" dirty="0" smtClean="0">
+                <a:latin typeface="Arial" pitchFamily="34" charset="0"/>
+                <a:cs typeface="Arial" pitchFamily="34" charset="0"/>
+              </a:rPr>
+              <a:t> </a:t>
+            </a:r>
+            <a:r>
+              <a:rPr lang="ru-RU" dirty="0" smtClean="0">
+                <a:latin typeface="Arial" pitchFamily="34" charset="0"/>
+                <a:cs typeface="Arial" pitchFamily="34" charset="0"/>
+              </a:rPr>
+              <a:t>(Услуги </a:t>
+            </a:r>
+            <a:r>
+              <a:rPr lang="ru-RU" dirty="0" smtClean="0">
+                <a:latin typeface="Arial" pitchFamily="34" charset="0"/>
+                <a:cs typeface="Arial" pitchFamily="34" charset="0"/>
+              </a:rPr>
+              <a:t>мастера)</a:t>
+            </a:r>
+            <a:endParaRPr lang="en-US" dirty="0" smtClean="0">
+              <a:latin typeface="Arial" pitchFamily="34" charset="0"/>
+              <a:cs typeface="Arial" pitchFamily="34" charset="0"/>
+            </a:endParaRPr>
+          </a:p>
+          <a:p>
+            <a:r>
+              <a:rPr lang="ru-RU" dirty="0" smtClean="0">
+                <a:latin typeface="Arial" pitchFamily="34" charset="0"/>
+                <a:cs typeface="Arial" pitchFamily="34" charset="0"/>
+              </a:rPr>
+              <a:t>Таблица </a:t>
+            </a:r>
+            <a:r>
+              <a:rPr lang="en-US" dirty="0" err="1" smtClean="0">
+                <a:latin typeface="Arial" pitchFamily="34" charset="0"/>
+                <a:cs typeface="Arial" pitchFamily="34" charset="0"/>
+              </a:rPr>
+              <a:t>ServiceCategories</a:t>
+            </a:r>
+            <a:endParaRPr lang="en-US" dirty="0" smtClean="0">
+              <a:latin typeface="Arial" pitchFamily="34" charset="0"/>
+              <a:cs typeface="Arial" pitchFamily="34" charset="0"/>
+            </a:endParaRPr>
+          </a:p>
+          <a:p>
+            <a:r>
+              <a:rPr lang="en-US" dirty="0" smtClean="0">
+                <a:latin typeface="Arial" pitchFamily="34" charset="0"/>
+                <a:cs typeface="Arial" pitchFamily="34" charset="0"/>
+              </a:rPr>
+              <a:t>(</a:t>
+            </a:r>
+            <a:r>
+              <a:rPr lang="ru-RU" dirty="0" smtClean="0">
+                <a:latin typeface="Arial" pitchFamily="34" charset="0"/>
+                <a:cs typeface="Arial" pitchFamily="34" charset="0"/>
+              </a:rPr>
+              <a:t>Категории </a:t>
+            </a:r>
+            <a:r>
+              <a:rPr lang="ru-RU" dirty="0" smtClean="0">
+                <a:latin typeface="Arial" pitchFamily="34" charset="0"/>
+                <a:cs typeface="Arial" pitchFamily="34" charset="0"/>
+              </a:rPr>
+              <a:t>услуг</a:t>
+            </a:r>
+            <a:r>
+              <a:rPr lang="ru-RU" dirty="0" smtClean="0">
+                <a:latin typeface="Arial" pitchFamily="34" charset="0"/>
+                <a:cs typeface="Arial" pitchFamily="34" charset="0"/>
+              </a:rPr>
+              <a:t>)</a:t>
+            </a:r>
+            <a:endParaRPr lang="en-US" dirty="0" smtClean="0">
+              <a:latin typeface="Arial" pitchFamily="34" charset="0"/>
+              <a:cs typeface="Arial" pitchFamily="34" charset="0"/>
+            </a:endParaRPr>
+          </a:p>
+          <a:p>
+            <a:endParaRPr lang="ru-RU" dirty="0" smtClean="0">
+              <a:latin typeface="Arial" pitchFamily="34" charset="0"/>
+              <a:cs typeface="Arial" pitchFamily="34" charset="0"/>
+            </a:endParaRPr>
+          </a:p>
+          <a:p>
+            <a:r>
+              <a:rPr lang="en-US" dirty="0" smtClean="0">
+                <a:latin typeface="Arial" pitchFamily="34" charset="0"/>
+                <a:cs typeface="Arial" pitchFamily="34" charset="0"/>
+              </a:rPr>
+              <a:t>–&gt; </a:t>
+            </a:r>
+            <a:r>
+              <a:rPr lang="ru-RU" dirty="0" smtClean="0">
+                <a:latin typeface="Arial" pitchFamily="34" charset="0"/>
+                <a:cs typeface="Arial" pitchFamily="34" charset="0"/>
+              </a:rPr>
+              <a:t>далее </a:t>
+            </a:r>
+            <a:r>
+              <a:rPr lang="ru-RU" dirty="0" smtClean="0">
+                <a:latin typeface="Arial" pitchFamily="34" charset="0"/>
+                <a:cs typeface="Arial" pitchFamily="34" charset="0"/>
+              </a:rPr>
+              <a:t>для </a:t>
+            </a:r>
+            <a:r>
+              <a:rPr lang="en-US" dirty="0" smtClean="0">
+                <a:latin typeface="Arial" pitchFamily="34" charset="0"/>
+                <a:cs typeface="Arial" pitchFamily="34" charset="0"/>
+              </a:rPr>
+              <a:t>Telegram </a:t>
+            </a:r>
+          </a:p>
+          <a:p>
+            <a:r>
+              <a:rPr lang="ru-RU" dirty="0" smtClean="0">
+                <a:latin typeface="Arial" pitchFamily="34" charset="0"/>
+                <a:cs typeface="Arial" pitchFamily="34" charset="0"/>
+              </a:rPr>
+              <a:t>Таблица </a:t>
+            </a:r>
+            <a:r>
+              <a:rPr lang="en-US" dirty="0" smtClean="0">
+                <a:latin typeface="Arial" pitchFamily="34" charset="0"/>
+                <a:cs typeface="Arial" pitchFamily="34" charset="0"/>
+              </a:rPr>
+              <a:t>Users </a:t>
+            </a:r>
+            <a:endParaRPr lang="en-US" dirty="0" smtClean="0">
+              <a:latin typeface="Arial" pitchFamily="34" charset="0"/>
+              <a:cs typeface="Arial" pitchFamily="34" charset="0"/>
+            </a:endParaRPr>
+          </a:p>
+          <a:p>
+            <a:r>
+              <a:rPr lang="en-US" dirty="0" smtClean="0">
+                <a:latin typeface="Arial" pitchFamily="34" charset="0"/>
+                <a:cs typeface="Arial" pitchFamily="34" charset="0"/>
+              </a:rPr>
+              <a:t>(</a:t>
+            </a:r>
+            <a:r>
+              <a:rPr lang="ru-RU" dirty="0" smtClean="0">
+                <a:latin typeface="Arial" pitchFamily="34" charset="0"/>
+                <a:cs typeface="Arial" pitchFamily="34" charset="0"/>
+              </a:rPr>
+              <a:t>Пользователи </a:t>
+            </a:r>
+            <a:r>
+              <a:rPr lang="ru-RU" dirty="0" smtClean="0">
+                <a:latin typeface="Arial" pitchFamily="34" charset="0"/>
+                <a:cs typeface="Arial" pitchFamily="34" charset="0"/>
+              </a:rPr>
+              <a:t>системы</a:t>
+            </a:r>
+            <a:r>
+              <a:rPr lang="en-US" dirty="0" smtClean="0">
+                <a:latin typeface="Arial" pitchFamily="34" charset="0"/>
+                <a:cs typeface="Arial" pitchFamily="34" charset="0"/>
+              </a:rPr>
+              <a:t>)</a:t>
+            </a:r>
+          </a:p>
+          <a:p>
+            <a:r>
+              <a:rPr lang="ru-RU" dirty="0" smtClean="0">
+                <a:latin typeface="Arial" pitchFamily="34" charset="0"/>
+                <a:cs typeface="Arial" pitchFamily="34" charset="0"/>
+              </a:rPr>
+              <a:t> </a:t>
+            </a:r>
+            <a:endParaRPr lang="ru-RU" dirty="0">
+              <a:latin typeface="Arial" pitchFamily="34" charset="0"/>
+              <a:cs typeface="Arial" pitchFamily="34" charset="0"/>
+            </a:endParaRPr>
+          </a:p>
+        </p:txBody>
+      </p:sp>
+      <p:pic>
+        <p:nvPicPr>
+          <p:cNvPr id="3074" name="Picture 2"/>
+          <p:cNvPicPr>
+            <a:picLocks noChangeAspect="1" noChangeArrowheads="1"/>
+          </p:cNvPicPr>
+          <p:nvPr/>
+        </p:nvPicPr>
+        <p:blipFill>
+          <a:blip r:embed="rId2" cstate="print"/>
+          <a:srcRect/>
+          <a:stretch>
+            <a:fillRect/>
+          </a:stretch>
+        </p:blipFill>
+        <p:spPr bwMode="auto">
+          <a:xfrm>
+            <a:off x="3059832" y="1196752"/>
+            <a:ext cx="5688180" cy="4896544"/>
+          </a:xfrm>
+          <a:prstGeom prst="rect">
+            <a:avLst/>
+          </a:prstGeom>
+          <a:noFill/>
+          <a:ln w="9525">
+            <a:noFill/>
+            <a:miter lim="800000"/>
+            <a:headEnd/>
+            <a:tailEnd/>
+          </a:ln>
+          <a:effectLst/>
+        </p:spPr>
+      </p:pic>
     </p:spTree>
   </p:cSld>
   <p:clrMapOvr>

</xml_diff>